<commit_message>
Add task for content classification.
</commit_message>
<xml_diff>
--- a/slides.pptx
+++ b/slides.pptx
@@ -5,7 +5,7 @@
     <p:sldMasterId id="2147483648" r:id="rId1"/>
   </p:sldMasterIdLst>
   <p:notesMasterIdLst>
-    <p:notesMasterId r:id="rId33"/>
+    <p:notesMasterId r:id="rId35"/>
   </p:notesMasterIdLst>
   <p:sldIdLst>
     <p:sldId id="326" r:id="rId2"/>
@@ -39,6 +39,8 @@
     <p:sldId id="339" r:id="rId30"/>
     <p:sldId id="340" r:id="rId31"/>
     <p:sldId id="341" r:id="rId32"/>
+    <p:sldId id="342" r:id="rId33"/>
+    <p:sldId id="343" r:id="rId34"/>
   </p:sldIdLst>
   <p:sldSz cx="12192000" cy="6858000"/>
   <p:notesSz cx="6858000" cy="9144000"/>
@@ -227,7 +229,7 @@
           <a:p>
             <a:fld id="{9D3F6AEA-44C2-D340-8C49-1DD8CC1E303A}" type="datetimeFigureOut">
               <a:rPr lang="en-FI" smtClean="0"/>
-              <a:t>19.8.2026</a:t>
+              <a:t>20.8.2026</a:t>
             </a:fld>
             <a:endParaRPr lang="en-FI"/>
           </a:p>
@@ -1160,7 +1162,7 @@
           <a:p>
             <a:fld id="{ED401605-E6B5-C84E-82B0-A2C01C1002AA}" type="datetimeFigureOut">
               <a:rPr lang="en-FI" smtClean="0"/>
-              <a:t>19.8.2026</a:t>
+              <a:t>20.8.2026</a:t>
             </a:fld>
             <a:endParaRPr lang="en-FI"/>
           </a:p>
@@ -1360,7 +1362,7 @@
           <a:p>
             <a:fld id="{ED401605-E6B5-C84E-82B0-A2C01C1002AA}" type="datetimeFigureOut">
               <a:rPr lang="en-FI" smtClean="0"/>
-              <a:t>19.8.2026</a:t>
+              <a:t>20.8.2026</a:t>
             </a:fld>
             <a:endParaRPr lang="en-FI"/>
           </a:p>
@@ -1570,7 +1572,7 @@
           <a:p>
             <a:fld id="{ED401605-E6B5-C84E-82B0-A2C01C1002AA}" type="datetimeFigureOut">
               <a:rPr lang="en-FI" smtClean="0"/>
-              <a:t>19.8.2026</a:t>
+              <a:t>20.8.2026</a:t>
             </a:fld>
             <a:endParaRPr lang="en-FI"/>
           </a:p>
@@ -1770,7 +1772,7 @@
           <a:p>
             <a:fld id="{ED401605-E6B5-C84E-82B0-A2C01C1002AA}" type="datetimeFigureOut">
               <a:rPr lang="en-FI" smtClean="0"/>
-              <a:t>19.8.2026</a:t>
+              <a:t>20.8.2026</a:t>
             </a:fld>
             <a:endParaRPr lang="en-FI"/>
           </a:p>
@@ -2046,7 +2048,7 @@
           <a:p>
             <a:fld id="{ED401605-E6B5-C84E-82B0-A2C01C1002AA}" type="datetimeFigureOut">
               <a:rPr lang="en-FI" smtClean="0"/>
-              <a:t>19.8.2026</a:t>
+              <a:t>20.8.2026</a:t>
             </a:fld>
             <a:endParaRPr lang="en-FI"/>
           </a:p>
@@ -2314,7 +2316,7 @@
           <a:p>
             <a:fld id="{ED401605-E6B5-C84E-82B0-A2C01C1002AA}" type="datetimeFigureOut">
               <a:rPr lang="en-FI" smtClean="0"/>
-              <a:t>19.8.2026</a:t>
+              <a:t>20.8.2026</a:t>
             </a:fld>
             <a:endParaRPr lang="en-FI"/>
           </a:p>
@@ -2729,7 +2731,7 @@
           <a:p>
             <a:fld id="{ED401605-E6B5-C84E-82B0-A2C01C1002AA}" type="datetimeFigureOut">
               <a:rPr lang="en-FI" smtClean="0"/>
-              <a:t>19.8.2026</a:t>
+              <a:t>20.8.2026</a:t>
             </a:fld>
             <a:endParaRPr lang="en-FI"/>
           </a:p>
@@ -2871,7 +2873,7 @@
           <a:p>
             <a:fld id="{ED401605-E6B5-C84E-82B0-A2C01C1002AA}" type="datetimeFigureOut">
               <a:rPr lang="en-FI" smtClean="0"/>
-              <a:t>19.8.2026</a:t>
+              <a:t>20.8.2026</a:t>
             </a:fld>
             <a:endParaRPr lang="en-FI"/>
           </a:p>
@@ -2984,7 +2986,7 @@
           <a:p>
             <a:fld id="{ED401605-E6B5-C84E-82B0-A2C01C1002AA}" type="datetimeFigureOut">
               <a:rPr lang="en-FI" smtClean="0"/>
-              <a:t>19.8.2026</a:t>
+              <a:t>20.8.2026</a:t>
             </a:fld>
             <a:endParaRPr lang="en-FI"/>
           </a:p>
@@ -3297,7 +3299,7 @@
           <a:p>
             <a:fld id="{ED401605-E6B5-C84E-82B0-A2C01C1002AA}" type="datetimeFigureOut">
               <a:rPr lang="en-FI" smtClean="0"/>
-              <a:t>19.8.2026</a:t>
+              <a:t>20.8.2026</a:t>
             </a:fld>
             <a:endParaRPr lang="en-FI"/>
           </a:p>
@@ -3586,7 +3588,7 @@
           <a:p>
             <a:fld id="{ED401605-E6B5-C84E-82B0-A2C01C1002AA}" type="datetimeFigureOut">
               <a:rPr lang="en-FI" smtClean="0"/>
-              <a:t>19.8.2026</a:t>
+              <a:t>20.8.2026</a:t>
             </a:fld>
             <a:endParaRPr lang="en-FI"/>
           </a:p>
@@ -3829,7 +3831,7 @@
           <a:p>
             <a:fld id="{ED401605-E6B5-C84E-82B0-A2C01C1002AA}" type="datetimeFigureOut">
               <a:rPr lang="en-FI" smtClean="0"/>
-              <a:t>19.8.2026</a:t>
+              <a:t>20.8.2026</a:t>
             </a:fld>
             <a:endParaRPr lang="en-FI"/>
           </a:p>
@@ -7375,7 +7377,7 @@
         <p:spPr>
           <a:xfrm>
             <a:off x="838200" y="3208504"/>
-            <a:ext cx="8455007" cy="1200329"/>
+            <a:ext cx="10157140" cy="1200329"/>
           </a:xfrm>
           <a:prstGeom prst="rect">
             <a:avLst/>
@@ -7396,7 +7398,7 @@
                 <a:solidFill>
                   <a:schemeClr val="bg1"/>
                 </a:solidFill>
-                <a:latin typeface="Calibri" panose="020F0502020204030204" pitchFamily="34" charset="0"/>
+                <a:latin typeface="Comfortaa" panose="020F0603070200060003" pitchFamily="34" charset="0"/>
                 <a:cs typeface="Calibri" panose="020F0502020204030204" pitchFamily="34" charset="0"/>
               </a:rPr>
               <a:t>Understanding LLMs as non-neutral approach to assess society</a:t>
@@ -7411,7 +7413,7 @@
                 <a:solidFill>
                   <a:schemeClr val="bg1"/>
                 </a:solidFill>
-                <a:latin typeface="Calibri" panose="020F0502020204030204" pitchFamily="34" charset="0"/>
+                <a:latin typeface="Comfortaa" panose="020F0603070200060003" pitchFamily="34" charset="0"/>
                 <a:cs typeface="Calibri" panose="020F0502020204030204" pitchFamily="34" charset="0"/>
               </a:rPr>
               <a:t>Examining LLM fine-tuned with spesific value-base</a:t>
@@ -7426,7 +7428,7 @@
                 <a:solidFill>
                   <a:schemeClr val="bg1"/>
                 </a:solidFill>
-                <a:latin typeface="Calibri" panose="020F0502020204030204" pitchFamily="34" charset="0"/>
+                <a:latin typeface="Comfortaa" panose="020F0603070200060003" pitchFamily="34" charset="0"/>
                 <a:cs typeface="Calibri" panose="020F0502020204030204" pitchFamily="34" charset="0"/>
               </a:rPr>
               <a:t>Code-review for fine-tuning</a:t>
@@ -11391,6 +11393,506 @@
     <p:extLst>
       <p:ext uri="{BB962C8B-B14F-4D97-AF65-F5344CB8AC3E}">
         <p14:creationId xmlns:p14="http://schemas.microsoft.com/office/powerpoint/2010/main" val="2076913565"/>
+      </p:ext>
+    </p:extLst>
+  </p:cSld>
+  <p:clrMapOvr>
+    <a:masterClrMapping/>
+  </p:clrMapOvr>
+</p:sld>
+</file>
+
+<file path=ppt/slides/slide32.xml><?xml version="1.0" encoding="utf-8"?>
+<p:sld xmlns:a="http://schemas.openxmlformats.org/drawingml/2006/main" xmlns:r="http://schemas.openxmlformats.org/officeDocument/2006/relationships" xmlns:p="http://schemas.openxmlformats.org/presentationml/2006/main">
+  <p:cSld>
+    <p:spTree>
+      <p:nvGrpSpPr>
+        <p:cNvPr id="1" name=""/>
+        <p:cNvGrpSpPr/>
+        <p:nvPr/>
+      </p:nvGrpSpPr>
+      <p:grpSpPr>
+        <a:xfrm>
+          <a:off x="0" y="0"/>
+          <a:ext cx="0" cy="0"/>
+          <a:chOff x="0" y="0"/>
+          <a:chExt cx="0" cy="0"/>
+        </a:xfrm>
+      </p:grpSpPr>
+      <p:sp>
+        <p:nvSpPr>
+          <p:cNvPr id="5" name="Title 4">
+            <a:extLst>
+              <a:ext uri="{FF2B5EF4-FFF2-40B4-BE49-F238E27FC236}">
+                <a16:creationId xmlns:a16="http://schemas.microsoft.com/office/drawing/2014/main" id="{A41DD118-8CDD-B17D-52FF-945BFE56BF16}"/>
+              </a:ext>
+            </a:extLst>
+          </p:cNvPr>
+          <p:cNvSpPr>
+            <a:spLocks noGrp="1"/>
+          </p:cNvSpPr>
+          <p:nvPr>
+            <p:ph type="title"/>
+          </p:nvPr>
+        </p:nvSpPr>
+        <p:spPr/>
+        <p:txBody>
+          <a:bodyPr/>
+          <a:lstStyle/>
+          <a:p>
+            <a:r>
+              <a:rPr lang="en-FI" dirty="0"/>
+              <a:t>Task for workshop</a:t>
+            </a:r>
+          </a:p>
+        </p:txBody>
+      </p:sp>
+      <p:sp>
+        <p:nvSpPr>
+          <p:cNvPr id="6" name="Content Placeholder 5">
+            <a:extLst>
+              <a:ext uri="{FF2B5EF4-FFF2-40B4-BE49-F238E27FC236}">
+                <a16:creationId xmlns:a16="http://schemas.microsoft.com/office/drawing/2014/main" id="{8C78EE3A-906A-0C5A-C65C-2B268D84A80D}"/>
+              </a:ext>
+            </a:extLst>
+          </p:cNvPr>
+          <p:cNvSpPr>
+            <a:spLocks noGrp="1"/>
+          </p:cNvSpPr>
+          <p:nvPr>
+            <p:ph idx="1"/>
+          </p:nvPr>
+        </p:nvSpPr>
+        <p:spPr>
+          <a:xfrm>
+            <a:off x="838200" y="1627004"/>
+            <a:ext cx="10515600" cy="1013268"/>
+          </a:xfrm>
+        </p:spPr>
+        <p:txBody>
+          <a:bodyPr>
+            <a:normAutofit fontScale="92500" lnSpcReduction="20000"/>
+          </a:bodyPr>
+          <a:lstStyle/>
+          <a:p>
+            <a:pPr marL="0" indent="0">
+              <a:buNone/>
+            </a:pPr>
+            <a:r>
+              <a:rPr lang="en-FI" dirty="0"/>
+              <a:t>Many want to use LLMs for content classification. Let’s do it with our Marxist model and without our Marxist model. (This seems to work with GPT2, </a:t>
+            </a:r>
+            <a:r>
+              <a:rPr lang="en-FI" i="1" dirty="0"/>
+              <a:t>not</a:t>
+            </a:r>
+            <a:r>
+              <a:rPr lang="en-FI" dirty="0"/>
+              <a:t> how cutting edge models would be prompted.)</a:t>
+            </a:r>
+          </a:p>
+        </p:txBody>
+      </p:sp>
+      <p:sp>
+        <p:nvSpPr>
+          <p:cNvPr id="8" name="TextBox 7">
+            <a:extLst>
+              <a:ext uri="{FF2B5EF4-FFF2-40B4-BE49-F238E27FC236}">
+                <a16:creationId xmlns:a16="http://schemas.microsoft.com/office/drawing/2014/main" id="{6D0904D5-DBBF-177C-DC9B-56B533D3027C}"/>
+              </a:ext>
+            </a:extLst>
+          </p:cNvPr>
+          <p:cNvSpPr txBox="1"/>
+          <p:nvPr/>
+        </p:nvSpPr>
+        <p:spPr>
+          <a:xfrm>
+            <a:off x="838200" y="2838893"/>
+            <a:ext cx="10515600" cy="3416320"/>
+          </a:xfrm>
+          <a:prstGeom prst="rect">
+            <a:avLst/>
+          </a:prstGeom>
+          <a:noFill/>
+        </p:spPr>
+        <p:txBody>
+          <a:bodyPr wrap="square">
+            <a:spAutoFit/>
+          </a:bodyPr>
+          <a:lstStyle/>
+          <a:p>
+            <a:pPr>
+              <a:lnSpc>
+                <a:spcPct val="100000"/>
+              </a:lnSpc>
+              <a:buNone/>
+            </a:pPr>
+            <a:r>
+              <a:rPr lang="en-FI" b="0" dirty="0">
+                <a:solidFill>
+                  <a:schemeClr val="tx1"/>
+                </a:solidFill>
+                <a:effectLst/>
+                <a:latin typeface="Consolas" panose="020B0609020204030204" pitchFamily="49" charset="0"/>
+                <a:cs typeface="Consolas" panose="020B0609020204030204" pitchFamily="49" charset="0"/>
+              </a:rPr>
+              <a:t>prompt = """</a:t>
+            </a:r>
+            <a:r>
+              <a:rPr lang="en-FI" b="0" dirty="0">
+                <a:solidFill>
+                  <a:schemeClr val="tx1"/>
+                </a:solidFill>
+                <a:effectLst/>
+                <a:highlight>
+                  <a:srgbClr val="FFFF00"/>
+                </a:highlight>
+                <a:latin typeface="Consolas" panose="020B0609020204030204" pitchFamily="49" charset="0"/>
+                <a:cs typeface="Consolas" panose="020B0609020204030204" pitchFamily="49" charset="0"/>
+              </a:rPr>
+              <a:t>Message: 'The new smartphone features a better camera and longer battery life.'</a:t>
+            </a:r>
+          </a:p>
+          <a:p>
+            <a:pPr>
+              <a:lnSpc>
+                <a:spcPct val="100000"/>
+              </a:lnSpc>
+              <a:buNone/>
+            </a:pPr>
+            <a:r>
+              <a:rPr lang="en-FI" b="0" dirty="0">
+                <a:solidFill>
+                  <a:schemeClr val="tx1"/>
+                </a:solidFill>
+                <a:effectLst/>
+                <a:highlight>
+                  <a:srgbClr val="FFFF00"/>
+                </a:highlight>
+                <a:latin typeface="Consolas" panose="020B0609020204030204" pitchFamily="49" charset="0"/>
+                <a:cs typeface="Consolas" panose="020B0609020204030204" pitchFamily="49" charset="0"/>
+              </a:rPr>
+              <a:t>Label: 0</a:t>
+            </a:r>
+          </a:p>
+          <a:p>
+            <a:pPr>
+              <a:lnSpc>
+                <a:spcPct val="100000"/>
+              </a:lnSpc>
+              <a:buNone/>
+            </a:pPr>
+            <a:r>
+              <a:rPr lang="en-FI" b="0" dirty="0">
+                <a:solidFill>
+                  <a:schemeClr val="tx1"/>
+                </a:solidFill>
+                <a:effectLst/>
+                <a:highlight>
+                  <a:srgbClr val="FFFF00"/>
+                </a:highlight>
+                <a:latin typeface="Consolas" panose="020B0609020204030204" pitchFamily="49" charset="0"/>
+                <a:cs typeface="Consolas" panose="020B0609020204030204" pitchFamily="49" charset="0"/>
+              </a:rPr>
+              <a:t>Message: 'The senator proposed a new bill to reform healthcare.'</a:t>
+            </a:r>
+          </a:p>
+          <a:p>
+            <a:pPr>
+              <a:lnSpc>
+                <a:spcPct val="100000"/>
+              </a:lnSpc>
+              <a:buNone/>
+            </a:pPr>
+            <a:r>
+              <a:rPr lang="en-FI" b="0" dirty="0">
+                <a:solidFill>
+                  <a:schemeClr val="tx1"/>
+                </a:solidFill>
+                <a:effectLst/>
+                <a:highlight>
+                  <a:srgbClr val="FFFF00"/>
+                </a:highlight>
+                <a:latin typeface="Consolas" panose="020B0609020204030204" pitchFamily="49" charset="0"/>
+                <a:cs typeface="Consolas" panose="020B0609020204030204" pitchFamily="49" charset="0"/>
+              </a:rPr>
+              <a:t>Label: 1</a:t>
+            </a:r>
+          </a:p>
+          <a:p>
+            <a:pPr>
+              <a:lnSpc>
+                <a:spcPct val="100000"/>
+              </a:lnSpc>
+              <a:buNone/>
+            </a:pPr>
+            <a:r>
+              <a:rPr lang="en-FI" b="0" dirty="0">
+                <a:solidFill>
+                  <a:schemeClr val="tx1"/>
+                </a:solidFill>
+                <a:effectLst/>
+                <a:highlight>
+                  <a:srgbClr val="FFFF00"/>
+                </a:highlight>
+                <a:latin typeface="Consolas" panose="020B0609020204030204" pitchFamily="49" charset="0"/>
+                <a:cs typeface="Consolas" panose="020B0609020204030204" pitchFamily="49" charset="0"/>
+              </a:rPr>
+              <a:t>Message: 'The local bakery is famous for its sourdough bread.'</a:t>
+            </a:r>
+          </a:p>
+          <a:p>
+            <a:pPr>
+              <a:lnSpc>
+                <a:spcPct val="100000"/>
+              </a:lnSpc>
+              <a:buNone/>
+            </a:pPr>
+            <a:r>
+              <a:rPr lang="en-FI" b="0" dirty="0">
+                <a:solidFill>
+                  <a:schemeClr val="tx1"/>
+                </a:solidFill>
+                <a:effectLst/>
+                <a:highlight>
+                  <a:srgbClr val="FFFF00"/>
+                </a:highlight>
+                <a:latin typeface="Consolas" panose="020B0609020204030204" pitchFamily="49" charset="0"/>
+                <a:cs typeface="Consolas" panose="020B0609020204030204" pitchFamily="49" charset="0"/>
+              </a:rPr>
+              <a:t>Label: 0</a:t>
+            </a:r>
+          </a:p>
+          <a:p>
+            <a:pPr>
+              <a:lnSpc>
+                <a:spcPct val="100000"/>
+              </a:lnSpc>
+              <a:buNone/>
+            </a:pPr>
+            <a:r>
+              <a:rPr lang="en-FI" b="0" dirty="0">
+                <a:solidFill>
+                  <a:schemeClr val="bg1"/>
+                </a:solidFill>
+                <a:effectLst/>
+                <a:highlight>
+                  <a:srgbClr val="FF00FF"/>
+                </a:highlight>
+                <a:latin typeface="Consolas" panose="020B0609020204030204" pitchFamily="49" charset="0"/>
+                <a:cs typeface="Consolas" panose="020B0609020204030204" pitchFamily="49" charset="0"/>
+              </a:rPr>
+              <a:t>Message: 'The government has announced new policies to improve the economy.'</a:t>
+            </a:r>
+          </a:p>
+          <a:p>
+            <a:pPr>
+              <a:lnSpc>
+                <a:spcPct val="100000"/>
+              </a:lnSpc>
+              <a:buNone/>
+            </a:pPr>
+            <a:r>
+              <a:rPr lang="en-FI" b="0" dirty="0">
+                <a:solidFill>
+                  <a:schemeClr val="bg1"/>
+                </a:solidFill>
+                <a:effectLst/>
+                <a:highlight>
+                  <a:srgbClr val="FF00FF"/>
+                </a:highlight>
+                <a:latin typeface="Consolas" panose="020B0609020204030204" pitchFamily="49" charset="0"/>
+                <a:cs typeface="Consolas" panose="020B0609020204030204" pitchFamily="49" charset="0"/>
+              </a:rPr>
+              <a:t>Label:</a:t>
+            </a:r>
+            <a:r>
+              <a:rPr lang="en-FI" b="0" dirty="0">
+                <a:solidFill>
+                  <a:schemeClr val="tx1"/>
+                </a:solidFill>
+                <a:effectLst/>
+                <a:latin typeface="Consolas" panose="020B0609020204030204" pitchFamily="49" charset="0"/>
+                <a:cs typeface="Consolas" panose="020B0609020204030204" pitchFamily="49" charset="0"/>
+              </a:rPr>
+              <a:t>"""</a:t>
+            </a:r>
+          </a:p>
+          <a:p>
+            <a:pPr>
+              <a:lnSpc>
+                <a:spcPct val="100000"/>
+              </a:lnSpc>
+              <a:buNone/>
+            </a:pPr>
+            <a:r>
+              <a:rPr lang="en-FI" b="0" dirty="0">
+                <a:solidFill>
+                  <a:schemeClr val="tx1"/>
+                </a:solidFill>
+                <a:effectLst/>
+                <a:latin typeface="Consolas" panose="020B0609020204030204" pitchFamily="49" charset="0"/>
+                <a:cs typeface="Consolas" panose="020B0609020204030204" pitchFamily="49" charset="0"/>
+              </a:rPr>
+              <a:t>print( finetuned(prompt)[0]['generated_text'] )</a:t>
+            </a:r>
+          </a:p>
+          <a:p>
+            <a:pPr>
+              <a:lnSpc>
+                <a:spcPct val="100000"/>
+              </a:lnSpc>
+              <a:buNone/>
+            </a:pPr>
+            <a:r>
+              <a:rPr lang="en-FI" b="0" dirty="0">
+                <a:solidFill>
+                  <a:schemeClr val="tx1"/>
+                </a:solidFill>
+                <a:effectLst/>
+                <a:latin typeface="Consolas" panose="020B0609020204030204" pitchFamily="49" charset="0"/>
+                <a:cs typeface="Consolas" panose="020B0609020204030204" pitchFamily="49" charset="0"/>
+              </a:rPr>
+              <a:t>print('===')</a:t>
+            </a:r>
+          </a:p>
+          <a:p>
+            <a:pPr>
+              <a:lnSpc>
+                <a:spcPct val="100000"/>
+              </a:lnSpc>
+              <a:buNone/>
+            </a:pPr>
+            <a:r>
+              <a:rPr lang="en-FI" b="0" dirty="0">
+                <a:solidFill>
+                  <a:schemeClr val="tx1"/>
+                </a:solidFill>
+                <a:effectLst/>
+                <a:latin typeface="Consolas" panose="020B0609020204030204" pitchFamily="49" charset="0"/>
+                <a:cs typeface="Consolas" panose="020B0609020204030204" pitchFamily="49" charset="0"/>
+              </a:rPr>
+              <a:t>print( baseline(prompt)[0]['generated_text'] )</a:t>
+            </a:r>
+            <a:endParaRPr lang="en-FI" sz="900" b="0" dirty="0">
+              <a:solidFill>
+                <a:srgbClr val="000000"/>
+              </a:solidFill>
+              <a:effectLst/>
+              <a:latin typeface="Consolas" panose="020B0609020204030204" pitchFamily="49" charset="0"/>
+              <a:cs typeface="Consolas" panose="020B0609020204030204" pitchFamily="49" charset="0"/>
+            </a:endParaRPr>
+          </a:p>
+        </p:txBody>
+      </p:sp>
+    </p:spTree>
+    <p:extLst>
+      <p:ext uri="{BB962C8B-B14F-4D97-AF65-F5344CB8AC3E}">
+        <p14:creationId xmlns:p14="http://schemas.microsoft.com/office/powerpoint/2010/main" val="3244068220"/>
+      </p:ext>
+    </p:extLst>
+  </p:cSld>
+  <p:clrMapOvr>
+    <a:masterClrMapping/>
+  </p:clrMapOvr>
+</p:sld>
+</file>
+
+<file path=ppt/slides/slide33.xml><?xml version="1.0" encoding="utf-8"?>
+<p:sld xmlns:a="http://schemas.openxmlformats.org/drawingml/2006/main" xmlns:r="http://schemas.openxmlformats.org/officeDocument/2006/relationships" xmlns:p="http://schemas.openxmlformats.org/presentationml/2006/main">
+  <p:cSld>
+    <p:spTree>
+      <p:nvGrpSpPr>
+        <p:cNvPr id="1" name=""/>
+        <p:cNvGrpSpPr/>
+        <p:nvPr/>
+      </p:nvGrpSpPr>
+      <p:grpSpPr>
+        <a:xfrm>
+          <a:off x="0" y="0"/>
+          <a:ext cx="0" cy="0"/>
+          <a:chOff x="0" y="0"/>
+          <a:chExt cx="0" cy="0"/>
+        </a:xfrm>
+      </p:grpSpPr>
+      <p:sp>
+        <p:nvSpPr>
+          <p:cNvPr id="2" name="Title 1">
+            <a:extLst>
+              <a:ext uri="{FF2B5EF4-FFF2-40B4-BE49-F238E27FC236}">
+                <a16:creationId xmlns:a16="http://schemas.microsoft.com/office/drawing/2014/main" id="{0B114E08-AE5F-79C0-F56B-12C2C7F3F734}"/>
+              </a:ext>
+            </a:extLst>
+          </p:cNvPr>
+          <p:cNvSpPr>
+            <a:spLocks noGrp="1"/>
+          </p:cNvSpPr>
+          <p:nvPr>
+            <p:ph type="title"/>
+          </p:nvPr>
+        </p:nvSpPr>
+        <p:spPr/>
+        <p:txBody>
+          <a:bodyPr/>
+          <a:lstStyle/>
+          <a:p>
+            <a:r>
+              <a:rPr lang="en-FI" dirty="0"/>
+              <a:t>Assingment</a:t>
+            </a:r>
+          </a:p>
+        </p:txBody>
+      </p:sp>
+      <p:sp>
+        <p:nvSpPr>
+          <p:cNvPr id="3" name="Content Placeholder 2">
+            <a:extLst>
+              <a:ext uri="{FF2B5EF4-FFF2-40B4-BE49-F238E27FC236}">
+                <a16:creationId xmlns:a16="http://schemas.microsoft.com/office/drawing/2014/main" id="{2FE668D2-8C68-CAB2-31F8-1021509A11A8}"/>
+              </a:ext>
+            </a:extLst>
+          </p:cNvPr>
+          <p:cNvSpPr>
+            <a:spLocks noGrp="1"/>
+          </p:cNvSpPr>
+          <p:nvPr>
+            <p:ph idx="1"/>
+          </p:nvPr>
+        </p:nvSpPr>
+        <p:spPr/>
+        <p:txBody>
+          <a:bodyPr/>
+          <a:lstStyle/>
+          <a:p>
+            <a:r>
+              <a:rPr lang="en-FI" dirty="0"/>
+              <a:t>Choose some material to work on that you want to classify (news headlines, Bluesky posts, …)</a:t>
+            </a:r>
+          </a:p>
+          <a:p>
+            <a:r>
+              <a:rPr lang="en-FI" dirty="0"/>
+              <a:t>Do some classification on it, like is the text content political or not</a:t>
+            </a:r>
+          </a:p>
+          <a:p>
+            <a:r>
+              <a:rPr lang="en-FI" dirty="0"/>
+              <a:t>Conduct analysis and record outcomes between two different models</a:t>
+            </a:r>
+          </a:p>
+          <a:p>
+            <a:r>
+              <a:rPr lang="en-FI" dirty="0"/>
+              <a:t>Present them with a suitable visualisation</a:t>
+            </a:r>
+          </a:p>
+        </p:txBody>
+      </p:sp>
+    </p:spTree>
+    <p:extLst>
+      <p:ext uri="{BB962C8B-B14F-4D97-AF65-F5344CB8AC3E}">
+        <p14:creationId xmlns:p14="http://schemas.microsoft.com/office/powerpoint/2010/main" val="3154754074"/>
       </p:ext>
     </p:extLst>
   </p:cSld>

</xml_diff>